<commit_message>
Add logo library and template logo extraction
</commit_message>
<xml_diff>
--- a/examples/paper_briefs/western_land_sea_corridor_scu_template_test.pptx
+++ b/examples/paper_briefs/western_land_sea_corridor_scu_template_test.pptx
@@ -3170,26 +3170,50 @@
           </a:p>
         </p:txBody>
       </p:sp>
-      <p:sp>
-        <p:nvSpPr>
-          <p:cNvPr id="4" name="Rectangle 3"/>
+      <p:pic>
+        <p:nvPicPr>
+          <p:cNvPr id="4" name="Picture 3" descr="scu_logo_badge_crop.png"/>
+          <p:cNvPicPr>
+            <a:picLocks noChangeAspect="1"/>
+          </p:cNvPicPr>
+          <p:nvPr/>
+        </p:nvPicPr>
+        <p:blipFill>
+          <a:blip r:embed="rId2"/>
+          <a:stretch>
+            <a:fillRect/>
+          </a:stretch>
+        </p:blipFill>
+        <p:spPr>
+          <a:xfrm>
+            <a:off x="9720072" y="411480"/>
+            <a:ext cx="1691640" cy="658368"/>
+          </a:xfrm>
+          <a:prstGeom prst="rect">
+            <a:avLst/>
+          </a:prstGeom>
+        </p:spPr>
+      </p:pic>
+      <p:sp>
+        <p:nvSpPr>
+          <p:cNvPr id="5" name="Rectangle 4"/>
           <p:cNvSpPr/>
           <p:nvPr/>
         </p:nvSpPr>
         <p:spPr>
           <a:xfrm>
-            <a:off x="9710928" y="429768"/>
-            <a:ext cx="1737360" cy="475488"/>
+            <a:off x="658368" y="6236208"/>
+            <a:ext cx="10881360" cy="9144"/>
           </a:xfrm>
           <a:prstGeom prst="rect">
             <a:avLst/>
           </a:prstGeom>
           <a:solidFill>
-            <a:srgbClr val="B80C0C"/>
+            <a:srgbClr val="EB5955"/>
           </a:solidFill>
           <a:ln>
             <a:solidFill>
-              <a:srgbClr val="B80C0C"/>
+              <a:srgbClr val="EB5955"/>
             </a:solidFill>
           </a:ln>
         </p:spPr>
@@ -3217,14 +3241,14 @@
       </p:sp>
       <p:sp>
         <p:nvSpPr>
-          <p:cNvPr id="5" name="TextBox 4"/>
+          <p:cNvPr id="6" name="TextBox 5"/>
           <p:cNvSpPr txBox="1"/>
           <p:nvPr/>
         </p:nvSpPr>
         <p:spPr>
           <a:xfrm>
-            <a:off x="9857232" y="530352"/>
-            <a:ext cx="1417320" cy="201168"/>
+            <a:off x="658368" y="6318504"/>
+            <a:ext cx="2560320" cy="256032"/>
           </a:xfrm>
           <a:prstGeom prst="rect">
             <a:avLst/>
@@ -3237,29 +3261,29 @@
           </a:bodyPr>
           <a:lstStyle/>
           <a:p>
-            <a:pPr algn="ctr"/>
-            <a:r>
-              <a:rPr sz="1000" b="1">
-                <a:solidFill>
-                  <a:srgbClr val="FFFFFF"/>
-                </a:solidFill>
-                <a:latin typeface="SimHei"/>
+            <a:pPr algn="l"/>
+            <a:r>
+              <a:rPr sz="1200" b="0">
+                <a:solidFill>
+                  <a:srgbClr val="969696"/>
+                </a:solidFill>
+                <a:latin typeface="SimSun"/>
               </a:rPr>
-              <a:t>四川大学</a:t>
-            </a:r>
-          </a:p>
-        </p:txBody>
-      </p:sp>
-      <p:sp>
-        <p:nvSpPr>
-          <p:cNvPr id="6" name="TextBox 5"/>
+              <a:t>海纳百川，有容乃大</a:t>
+            </a:r>
+          </a:p>
+        </p:txBody>
+      </p:sp>
+      <p:sp>
+        <p:nvSpPr>
+          <p:cNvPr id="7" name="TextBox 6"/>
           <p:cNvSpPr txBox="1"/>
           <p:nvPr/>
         </p:nvSpPr>
         <p:spPr>
           <a:xfrm>
-            <a:off x="9857232" y="731520"/>
-            <a:ext cx="1417320" cy="118872"/>
+            <a:off x="9646920" y="6318504"/>
+            <a:ext cx="1920240" cy="256032"/>
           </a:xfrm>
           <a:prstGeom prst="rect">
             <a:avLst/>
@@ -3272,39 +3296,74 @@
           </a:bodyPr>
           <a:lstStyle/>
           <a:p>
-            <a:pPr algn="ctr"/>
-            <a:r>
-              <a:rPr sz="500" b="1">
-                <a:solidFill>
-                  <a:srgbClr val="FFFFFF"/>
-                </a:solidFill>
-                <a:latin typeface="Arial"/>
+            <a:pPr algn="r"/>
+            <a:r>
+              <a:rPr sz="1200" b="0">
+                <a:solidFill>
+                  <a:srgbClr val="969696"/>
+                </a:solidFill>
+                <a:latin typeface="SimSun"/>
               </a:rPr>
-              <a:t>SICHUAN UNIVERSITY</a:t>
-            </a:r>
-          </a:p>
-        </p:txBody>
-      </p:sp>
-      <p:sp>
-        <p:nvSpPr>
-          <p:cNvPr id="7" name="Rectangle 6"/>
+              <a:t>www.scu.edu.cn/</a:t>
+            </a:r>
+          </a:p>
+        </p:txBody>
+      </p:sp>
+      <p:sp>
+        <p:nvSpPr>
+          <p:cNvPr id="8" name="TextBox 7"/>
+          <p:cNvSpPr txBox="1"/>
+          <p:nvPr/>
+        </p:nvSpPr>
+        <p:spPr>
+          <a:xfrm>
+            <a:off x="1417320" y="1691640"/>
+            <a:ext cx="4480560" cy="384048"/>
+          </a:xfrm>
+          <a:prstGeom prst="rect">
+            <a:avLst/>
+          </a:prstGeom>
+          <a:noFill/>
+        </p:spPr>
+        <p:txBody>
+          <a:bodyPr wrap="square" lIns="54864" rIns="54864" tIns="27432" bIns="27432">
+            <a:noAutofit/>
+          </a:bodyPr>
+          <a:lstStyle/>
+          <a:p>
+            <a:pPr algn="l"/>
+            <a:r>
+              <a:rPr sz="2200" b="1">
+                <a:solidFill>
+                  <a:srgbClr val="B80C0C"/>
+                </a:solidFill>
+                <a:latin typeface="SimHei"/>
+              </a:rPr>
+              <a:t>核心问题</a:t>
+            </a:r>
+          </a:p>
+        </p:txBody>
+      </p:sp>
+      <p:sp>
+        <p:nvSpPr>
+          <p:cNvPr id="9" name="Rectangle 8"/>
           <p:cNvSpPr/>
           <p:nvPr/>
         </p:nvSpPr>
         <p:spPr>
           <a:xfrm>
-            <a:off x="658368" y="6236208"/>
-            <a:ext cx="10881360" cy="9144"/>
+            <a:off x="658368" y="2331720"/>
+            <a:ext cx="10835640" cy="2240280"/>
           </a:xfrm>
           <a:prstGeom prst="rect">
             <a:avLst/>
           </a:prstGeom>
           <a:solidFill>
-            <a:srgbClr val="EB5955"/>
+            <a:srgbClr val="B80C0C"/>
           </a:solidFill>
           <a:ln>
             <a:solidFill>
-              <a:srgbClr val="EB5955"/>
+              <a:srgbClr val="B80C0C"/>
             </a:solidFill>
           </a:ln>
         </p:spPr>
@@ -3332,14 +3391,14 @@
       </p:sp>
       <p:sp>
         <p:nvSpPr>
-          <p:cNvPr id="8" name="TextBox 7"/>
+          <p:cNvPr id="10" name="TextBox 9"/>
           <p:cNvSpPr txBox="1"/>
           <p:nvPr/>
         </p:nvSpPr>
         <p:spPr>
           <a:xfrm>
-            <a:off x="658368" y="6318504"/>
-            <a:ext cx="2560320" cy="256032"/>
+            <a:off x="1234440" y="2606040"/>
+            <a:ext cx="4800600" cy="1463040"/>
           </a:xfrm>
           <a:prstGeom prst="rect">
             <a:avLst/>
@@ -3347,90 +3406,40 @@
           <a:noFill/>
         </p:spPr>
         <p:txBody>
-          <a:bodyPr wrap="square" lIns="54864" rIns="54864" tIns="27432" bIns="27432">
+          <a:bodyPr wrap="square" lIns="73152" rIns="73152">
             <a:noAutofit/>
           </a:bodyPr>
           <a:lstStyle/>
           <a:p>
-            <a:pPr algn="l"/>
-            <a:r>
-              <a:rPr sz="1200" b="0">
-                <a:solidFill>
-                  <a:srgbClr val="969696"/>
+            <a:pPr>
+              <a:spcAft>
+                <a:spcPts val="500"/>
+              </a:spcAft>
+            </a:pPr>
+            <a:r>
+              <a:rPr sz="1700">
+                <a:solidFill>
+                  <a:srgbClr val="FFFFFF"/>
                 </a:solidFill>
                 <a:latin typeface="SimSun"/>
               </a:rPr>
-              <a:t>海纳百川，有容乃大</a:t>
-            </a:r>
-          </a:p>
-        </p:txBody>
-      </p:sp>
-      <p:sp>
-        <p:nvSpPr>
-          <p:cNvPr id="9" name="TextBox 8"/>
-          <p:cNvSpPr txBox="1"/>
-          <p:nvPr/>
-        </p:nvSpPr>
-        <p:spPr>
-          <a:xfrm>
-            <a:off x="9646920" y="6318504"/>
-            <a:ext cx="1920240" cy="256032"/>
-          </a:xfrm>
-          <a:prstGeom prst="rect">
-            <a:avLst/>
-          </a:prstGeom>
-          <a:noFill/>
-        </p:spPr>
-        <p:txBody>
-          <a:bodyPr wrap="square" lIns="54864" rIns="54864" tIns="27432" bIns="27432">
-            <a:noAutofit/>
-          </a:bodyPr>
-          <a:lstStyle/>
-          <a:p>
-            <a:pPr algn="r"/>
-            <a:r>
-              <a:rPr sz="1200" b="0">
-                <a:solidFill>
-                  <a:srgbClr val="969696"/>
+              <a:t>“西部陆海新通道”如何从交通物流线路升级为开放型通道经济发展轴？</a:t>
+            </a:r>
+          </a:p>
+          <a:p>
+            <a:pPr>
+              <a:spcAft>
+                <a:spcPts val="500"/>
+              </a:spcAft>
+            </a:pPr>
+            <a:r>
+              <a:rPr sz="1700">
+                <a:solidFill>
+                  <a:srgbClr val="FFFFFF"/>
                 </a:solidFill>
                 <a:latin typeface="SimSun"/>
               </a:rPr>
-              <a:t>www.scu.edu.cn/</a:t>
-            </a:r>
-          </a:p>
-        </p:txBody>
-      </p:sp>
-      <p:sp>
-        <p:nvSpPr>
-          <p:cNvPr id="10" name="TextBox 9"/>
-          <p:cNvSpPr txBox="1"/>
-          <p:nvPr/>
-        </p:nvSpPr>
-        <p:spPr>
-          <a:xfrm>
-            <a:off x="1417320" y="1691640"/>
-            <a:ext cx="4480560" cy="384048"/>
-          </a:xfrm>
-          <a:prstGeom prst="rect">
-            <a:avLst/>
-          </a:prstGeom>
-          <a:noFill/>
-        </p:spPr>
-        <p:txBody>
-          <a:bodyPr wrap="square" lIns="54864" rIns="54864" tIns="27432" bIns="27432">
-            <a:noAutofit/>
-          </a:bodyPr>
-          <a:lstStyle/>
-          <a:p>
-            <a:pPr algn="l"/>
-            <a:r>
-              <a:rPr sz="2200" b="1">
-                <a:solidFill>
-                  <a:srgbClr val="B80C0C"/>
-                </a:solidFill>
-                <a:latin typeface="SimHei"/>
-              </a:rPr>
-              <a:t>核心问题</a:t>
+              <a:t>论文把通道建设放入国内区域经济联系与国际经贸竞争互补两个尺度中分析。</a:t>
             </a:r>
           </a:p>
         </p:txBody>
@@ -3443,18 +3452,18 @@
         </p:nvSpPr>
         <p:spPr>
           <a:xfrm>
-            <a:off x="658368" y="2331720"/>
-            <a:ext cx="10835640" cy="2240280"/>
+            <a:off x="6537960" y="1627632"/>
+            <a:ext cx="3886200" cy="2194560"/>
           </a:xfrm>
           <a:prstGeom prst="rect">
             <a:avLst/>
           </a:prstGeom>
           <a:solidFill>
-            <a:srgbClr val="B80C0C"/>
+            <a:srgbClr val="FFFFFF"/>
           </a:solidFill>
           <a:ln>
             <a:solidFill>
-              <a:srgbClr val="B80C0C"/>
+              <a:srgbClr val="EB5955"/>
             </a:solidFill>
           </a:ln>
         </p:spPr>
@@ -3488,8 +3497,43 @@
         </p:nvSpPr>
         <p:spPr>
           <a:xfrm>
-            <a:off x="1234440" y="2606040"/>
-            <a:ext cx="4800600" cy="1463040"/>
+            <a:off x="6684264" y="1737360"/>
+            <a:ext cx="3593592" cy="292608"/>
+          </a:xfrm>
+          <a:prstGeom prst="rect">
+            <a:avLst/>
+          </a:prstGeom>
+          <a:noFill/>
+        </p:spPr>
+        <p:txBody>
+          <a:bodyPr wrap="square" lIns="54864" rIns="54864" tIns="27432" bIns="27432">
+            <a:noAutofit/>
+          </a:bodyPr>
+          <a:lstStyle/>
+          <a:p>
+            <a:pPr algn="l"/>
+            <a:r>
+              <a:rPr sz="1600" b="1">
+                <a:solidFill>
+                  <a:srgbClr val="B80C0C"/>
+                </a:solidFill>
+                <a:latin typeface="SimHei"/>
+              </a:rPr>
+              <a:t>理论基础</a:t>
+            </a:r>
+          </a:p>
+        </p:txBody>
+      </p:sp>
+      <p:sp>
+        <p:nvSpPr>
+          <p:cNvPr id="13" name="TextBox 12"/>
+          <p:cNvSpPr txBox="1"/>
+          <p:nvPr/>
+        </p:nvSpPr>
+        <p:spPr>
+          <a:xfrm>
+            <a:off x="6684264" y="2103120"/>
+            <a:ext cx="3593592" cy="1609344"/>
           </a:xfrm>
           <a:prstGeom prst="rect">
             <a:avLst/>
@@ -3508,13 +3552,13 @@
               </a:spcAft>
             </a:pPr>
             <a:r>
-              <a:rPr sz="1700">
-                <a:solidFill>
-                  <a:srgbClr val="FFFFFF"/>
+              <a:rPr sz="1200">
+                <a:solidFill>
+                  <a:srgbClr val="181818"/>
                 </a:solidFill>
                 <a:latin typeface="SimSun"/>
               </a:rPr>
-              <a:t>“西部陆海新通道”如何从交通物流线路升级为开放型通道经济发展轴？</a:t>
+              <a:t>点轴理论：通道串联增长极，形成区域经济联系。</a:t>
             </a:r>
           </a:p>
           <a:p>
@@ -3524,118 +3568,15 @@
               </a:spcAft>
             </a:pPr>
             <a:r>
-              <a:rPr sz="1700">
-                <a:solidFill>
-                  <a:srgbClr val="FFFFFF"/>
+              <a:rPr sz="1200">
+                <a:solidFill>
+                  <a:srgbClr val="181818"/>
                 </a:solidFill>
                 <a:latin typeface="SimSun"/>
               </a:rPr>
-              <a:t>论文把通道建设放入国内区域经济联系与国际经贸竞争互补两个尺度中分析。</a:t>
-            </a:r>
-          </a:p>
-        </p:txBody>
-      </p:sp>
-      <p:sp>
-        <p:nvSpPr>
-          <p:cNvPr id="13" name="Rectangle 12"/>
-          <p:cNvSpPr/>
-          <p:nvPr/>
-        </p:nvSpPr>
-        <p:spPr>
-          <a:xfrm>
-            <a:off x="6537960" y="1627632"/>
-            <a:ext cx="3886200" cy="2194560"/>
-          </a:xfrm>
-          <a:prstGeom prst="rect">
-            <a:avLst/>
-          </a:prstGeom>
-          <a:solidFill>
-            <a:srgbClr val="FFFFFF"/>
-          </a:solidFill>
-          <a:ln>
-            <a:solidFill>
-              <a:srgbClr val="EB5955"/>
-            </a:solidFill>
-          </a:ln>
-        </p:spPr>
-        <p:style>
-          <a:lnRef idx="1">
-            <a:schemeClr val="accent1"/>
-          </a:lnRef>
-          <a:fillRef idx="3">
-            <a:schemeClr val="accent1"/>
-          </a:fillRef>
-          <a:effectRef idx="2">
-            <a:schemeClr val="accent1"/>
-          </a:effectRef>
-          <a:fontRef idx="minor">
-            <a:schemeClr val="lt1"/>
-          </a:fontRef>
-        </p:style>
-        <p:txBody>
-          <a:bodyPr rtlCol="0" anchor="ctr"/>
-          <a:lstStyle/>
-          <a:p>
-            <a:pPr algn="ctr"/>
-          </a:p>
-        </p:txBody>
-      </p:sp>
-      <p:sp>
-        <p:nvSpPr>
-          <p:cNvPr id="14" name="TextBox 13"/>
-          <p:cNvSpPr txBox="1"/>
-          <p:nvPr/>
-        </p:nvSpPr>
-        <p:spPr>
-          <a:xfrm>
-            <a:off x="6684264" y="1737360"/>
-            <a:ext cx="3593592" cy="292608"/>
-          </a:xfrm>
-          <a:prstGeom prst="rect">
-            <a:avLst/>
-          </a:prstGeom>
-          <a:noFill/>
-        </p:spPr>
-        <p:txBody>
-          <a:bodyPr wrap="square" lIns="54864" rIns="54864" tIns="27432" bIns="27432">
-            <a:noAutofit/>
-          </a:bodyPr>
-          <a:lstStyle/>
-          <a:p>
-            <a:pPr algn="l"/>
-            <a:r>
-              <a:rPr sz="1600" b="1">
-                <a:solidFill>
-                  <a:srgbClr val="B80C0C"/>
-                </a:solidFill>
-                <a:latin typeface="SimHei"/>
-              </a:rPr>
-              <a:t>理论基础</a:t>
-            </a:r>
-          </a:p>
-        </p:txBody>
-      </p:sp>
-      <p:sp>
-        <p:nvSpPr>
-          <p:cNvPr id="15" name="TextBox 14"/>
-          <p:cNvSpPr txBox="1"/>
-          <p:nvPr/>
-        </p:nvSpPr>
-        <p:spPr>
-          <a:xfrm>
-            <a:off x="6684264" y="2103120"/>
-            <a:ext cx="3593592" cy="1609344"/>
-          </a:xfrm>
-          <a:prstGeom prst="rect">
-            <a:avLst/>
-          </a:prstGeom>
-          <a:noFill/>
-        </p:spPr>
-        <p:txBody>
-          <a:bodyPr wrap="square" lIns="73152" rIns="73152">
-            <a:noAutofit/>
-          </a:bodyPr>
-          <a:lstStyle/>
+              <a:t>国际贸易理论：比较优势、规模经济和产业分工共同解释开放效应。</a:t>
+            </a:r>
+          </a:p>
           <a:p>
             <a:pPr>
               <a:spcAft>
@@ -3649,38 +3590,6 @@
                 </a:solidFill>
                 <a:latin typeface="SimSun"/>
               </a:rPr>
-              <a:t>点轴理论：通道串联增长极，形成区域经济联系。</a:t>
-            </a:r>
-          </a:p>
-          <a:p>
-            <a:pPr>
-              <a:spcAft>
-                <a:spcPts val="500"/>
-              </a:spcAft>
-            </a:pPr>
-            <a:r>
-              <a:rPr sz="1200">
-                <a:solidFill>
-                  <a:srgbClr val="181818"/>
-                </a:solidFill>
-                <a:latin typeface="SimSun"/>
-              </a:rPr>
-              <a:t>国际贸易理论：比较优势、规模经济和产业分工共同解释开放效应。</a:t>
-            </a:r>
-          </a:p>
-          <a:p>
-            <a:pPr>
-              <a:spcAft>
-                <a:spcPts val="500"/>
-              </a:spcAft>
-            </a:pPr>
-            <a:r>
-              <a:rPr sz="1200">
-                <a:solidFill>
-                  <a:srgbClr val="181818"/>
-                </a:solidFill>
-                <a:latin typeface="SimSun"/>
-              </a:rPr>
               <a:t>新经济地理：贸易成本下降会重塑产业集聚与空间格局。</a:t>
             </a:r>
           </a:p>
@@ -3688,14 +3597,14 @@
       </p:sp>
       <p:sp>
         <p:nvSpPr>
-          <p:cNvPr id="16" name="TextBox 15"/>
+          <p:cNvPr id="14" name="TextBox 13"/>
           <p:cNvSpPr txBox="1"/>
           <p:nvPr/>
         </p:nvSpPr>
         <p:spPr>
           <a:xfrm>
-            <a:off x="1051560" y="4892040"/>
-            <a:ext cx="9875520" cy="640080"/>
+            <a:off x="868680" y="4892040"/>
+            <a:ext cx="10241280" cy="640080"/>
           </a:xfrm>
           <a:prstGeom prst="rect">
             <a:avLst/>
@@ -3710,7 +3619,7 @@
           <a:p>
             <a:pPr algn="ctr"/>
             <a:r>
-              <a:rPr sz="1600" b="1">
+              <a:rPr sz="1400" b="1">
                 <a:solidFill>
                   <a:srgbClr val="181818"/>
                 </a:solidFill>
@@ -3819,26 +3728,50 @@
           </a:p>
         </p:txBody>
       </p:sp>
-      <p:sp>
-        <p:nvSpPr>
-          <p:cNvPr id="4" name="Rectangle 3"/>
+      <p:pic>
+        <p:nvPicPr>
+          <p:cNvPr id="4" name="Picture 3" descr="scu_logo_badge_crop.png"/>
+          <p:cNvPicPr>
+            <a:picLocks noChangeAspect="1"/>
+          </p:cNvPicPr>
+          <p:nvPr/>
+        </p:nvPicPr>
+        <p:blipFill>
+          <a:blip r:embed="rId2"/>
+          <a:stretch>
+            <a:fillRect/>
+          </a:stretch>
+        </p:blipFill>
+        <p:spPr>
+          <a:xfrm>
+            <a:off x="9720072" y="411480"/>
+            <a:ext cx="1691640" cy="658368"/>
+          </a:xfrm>
+          <a:prstGeom prst="rect">
+            <a:avLst/>
+          </a:prstGeom>
+        </p:spPr>
+      </p:pic>
+      <p:sp>
+        <p:nvSpPr>
+          <p:cNvPr id="5" name="Rectangle 4"/>
           <p:cNvSpPr/>
           <p:nvPr/>
         </p:nvSpPr>
         <p:spPr>
           <a:xfrm>
-            <a:off x="9710928" y="429768"/>
-            <a:ext cx="1737360" cy="475488"/>
+            <a:off x="658368" y="6236208"/>
+            <a:ext cx="10881360" cy="9144"/>
           </a:xfrm>
           <a:prstGeom prst="rect">
             <a:avLst/>
           </a:prstGeom>
           <a:solidFill>
-            <a:srgbClr val="B80C0C"/>
+            <a:srgbClr val="EB5955"/>
           </a:solidFill>
           <a:ln>
             <a:solidFill>
-              <a:srgbClr val="B80C0C"/>
+              <a:srgbClr val="EB5955"/>
             </a:solidFill>
           </a:ln>
         </p:spPr>
@@ -3866,14 +3799,14 @@
       </p:sp>
       <p:sp>
         <p:nvSpPr>
-          <p:cNvPr id="5" name="TextBox 4"/>
+          <p:cNvPr id="6" name="TextBox 5"/>
           <p:cNvSpPr txBox="1"/>
           <p:nvPr/>
         </p:nvSpPr>
         <p:spPr>
           <a:xfrm>
-            <a:off x="9857232" y="530352"/>
-            <a:ext cx="1417320" cy="201168"/>
+            <a:off x="658368" y="6318504"/>
+            <a:ext cx="2560320" cy="256032"/>
           </a:xfrm>
           <a:prstGeom prst="rect">
             <a:avLst/>
@@ -3886,29 +3819,29 @@
           </a:bodyPr>
           <a:lstStyle/>
           <a:p>
-            <a:pPr algn="ctr"/>
-            <a:r>
-              <a:rPr sz="1000" b="1">
-                <a:solidFill>
-                  <a:srgbClr val="FFFFFF"/>
-                </a:solidFill>
-                <a:latin typeface="SimHei"/>
+            <a:pPr algn="l"/>
+            <a:r>
+              <a:rPr sz="1200" b="0">
+                <a:solidFill>
+                  <a:srgbClr val="969696"/>
+                </a:solidFill>
+                <a:latin typeface="SimSun"/>
               </a:rPr>
-              <a:t>四川大学</a:t>
-            </a:r>
-          </a:p>
-        </p:txBody>
-      </p:sp>
-      <p:sp>
-        <p:nvSpPr>
-          <p:cNvPr id="6" name="TextBox 5"/>
+              <a:t>海纳百川，有容乃大</a:t>
+            </a:r>
+          </a:p>
+        </p:txBody>
+      </p:sp>
+      <p:sp>
+        <p:nvSpPr>
+          <p:cNvPr id="7" name="TextBox 6"/>
           <p:cNvSpPr txBox="1"/>
           <p:nvPr/>
         </p:nvSpPr>
         <p:spPr>
           <a:xfrm>
-            <a:off x="9857232" y="731520"/>
-            <a:ext cx="1417320" cy="118872"/>
+            <a:off x="9646920" y="6318504"/>
+            <a:ext cx="1920240" cy="256032"/>
           </a:xfrm>
           <a:prstGeom prst="rect">
             <a:avLst/>
@@ -3921,29 +3854,69 @@
           </a:bodyPr>
           <a:lstStyle/>
           <a:p>
+            <a:pPr algn="r"/>
+            <a:r>
+              <a:rPr sz="1200" b="0">
+                <a:solidFill>
+                  <a:srgbClr val="969696"/>
+                </a:solidFill>
+                <a:latin typeface="SimSun"/>
+              </a:rPr>
+              <a:t>www.scu.edu.cn/</a:t>
+            </a:r>
+          </a:p>
+        </p:txBody>
+      </p:sp>
+      <p:sp>
+        <p:nvSpPr>
+          <p:cNvPr id="8" name="TextBox 7"/>
+          <p:cNvSpPr txBox="1"/>
+          <p:nvPr/>
+        </p:nvSpPr>
+        <p:spPr>
+          <a:xfrm>
+            <a:off x="868680" y="1417320"/>
+            <a:ext cx="1920240" cy="3337560"/>
+          </a:xfrm>
+          <a:prstGeom prst="rect">
+            <a:avLst/>
+          </a:prstGeom>
+          <a:noFill/>
+        </p:spPr>
+        <p:txBody>
+          <a:bodyPr wrap="square" lIns="54864" rIns="54864" tIns="27432" bIns="27432">
+            <a:noAutofit/>
+          </a:bodyPr>
+          <a:lstStyle/>
+          <a:p>
             <a:pPr algn="ctr"/>
             <a:r>
-              <a:rPr sz="500" b="1">
-                <a:solidFill>
-                  <a:srgbClr val="FFFFFF"/>
-                </a:solidFill>
-                <a:latin typeface="Arial"/>
+              <a:rPr sz="2400" b="1">
+                <a:solidFill>
+                  <a:srgbClr val="B80C0C"/>
+                </a:solidFill>
+                <a:latin typeface="SimHei"/>
               </a:rPr>
-              <a:t>SICHUAN UNIVERSITY</a:t>
-            </a:r>
-          </a:p>
-        </p:txBody>
-      </p:sp>
-      <p:sp>
-        <p:nvSpPr>
-          <p:cNvPr id="7" name="Rectangle 6"/>
+              <a:t>二
+元
+尺
+度
+分
+析</a:t>
+            </a:r>
+          </a:p>
+        </p:txBody>
+      </p:sp>
+      <p:sp>
+        <p:nvSpPr>
+          <p:cNvPr id="9" name="Rectangle 8"/>
           <p:cNvSpPr/>
           <p:nvPr/>
         </p:nvSpPr>
         <p:spPr>
           <a:xfrm>
-            <a:off x="658368" y="6236208"/>
-            <a:ext cx="10881360" cy="9144"/>
+            <a:off x="2331720" y="1417320"/>
+            <a:ext cx="18288" cy="3429000"/>
           </a:xfrm>
           <a:prstGeom prst="rect">
             <a:avLst/>
@@ -3981,14 +3954,14 @@
       </p:sp>
       <p:sp>
         <p:nvSpPr>
-          <p:cNvPr id="8" name="TextBox 7"/>
+          <p:cNvPr id="10" name="TextBox 9"/>
           <p:cNvSpPr txBox="1"/>
           <p:nvPr/>
         </p:nvSpPr>
         <p:spPr>
           <a:xfrm>
-            <a:off x="658368" y="6318504"/>
-            <a:ext cx="2560320" cy="256032"/>
+            <a:off x="2971800" y="1325880"/>
+            <a:ext cx="6492240" cy="274320"/>
           </a:xfrm>
           <a:prstGeom prst="rect">
             <a:avLst/>
@@ -4003,161 +3976,6 @@
           <a:p>
             <a:pPr algn="l"/>
             <a:r>
-              <a:rPr sz="1200" b="0">
-                <a:solidFill>
-                  <a:srgbClr val="969696"/>
-                </a:solidFill>
-                <a:latin typeface="SimSun"/>
-              </a:rPr>
-              <a:t>海纳百川，有容乃大</a:t>
-            </a:r>
-          </a:p>
-        </p:txBody>
-      </p:sp>
-      <p:sp>
-        <p:nvSpPr>
-          <p:cNvPr id="9" name="TextBox 8"/>
-          <p:cNvSpPr txBox="1"/>
-          <p:nvPr/>
-        </p:nvSpPr>
-        <p:spPr>
-          <a:xfrm>
-            <a:off x="9646920" y="6318504"/>
-            <a:ext cx="1920240" cy="256032"/>
-          </a:xfrm>
-          <a:prstGeom prst="rect">
-            <a:avLst/>
-          </a:prstGeom>
-          <a:noFill/>
-        </p:spPr>
-        <p:txBody>
-          <a:bodyPr wrap="square" lIns="54864" rIns="54864" tIns="27432" bIns="27432">
-            <a:noAutofit/>
-          </a:bodyPr>
-          <a:lstStyle/>
-          <a:p>
-            <a:pPr algn="r"/>
-            <a:r>
-              <a:rPr sz="1200" b="0">
-                <a:solidFill>
-                  <a:srgbClr val="969696"/>
-                </a:solidFill>
-                <a:latin typeface="SimSun"/>
-              </a:rPr>
-              <a:t>www.scu.edu.cn/</a:t>
-            </a:r>
-          </a:p>
-        </p:txBody>
-      </p:sp>
-      <p:sp>
-        <p:nvSpPr>
-          <p:cNvPr id="10" name="TextBox 9"/>
-          <p:cNvSpPr txBox="1"/>
-          <p:nvPr/>
-        </p:nvSpPr>
-        <p:spPr>
-          <a:xfrm>
-            <a:off x="868680" y="1417320"/>
-            <a:ext cx="1920240" cy="3337560"/>
-          </a:xfrm>
-          <a:prstGeom prst="rect">
-            <a:avLst/>
-          </a:prstGeom>
-          <a:noFill/>
-        </p:spPr>
-        <p:txBody>
-          <a:bodyPr wrap="square" lIns="54864" rIns="54864" tIns="27432" bIns="27432">
-            <a:noAutofit/>
-          </a:bodyPr>
-          <a:lstStyle/>
-          <a:p>
-            <a:pPr algn="ctr"/>
-            <a:r>
-              <a:rPr sz="2400" b="1">
-                <a:solidFill>
-                  <a:srgbClr val="B80C0C"/>
-                </a:solidFill>
-                <a:latin typeface="SimHei"/>
-              </a:rPr>
-              <a:t>二
-元
-尺
-度
-分
-析</a:t>
-            </a:r>
-          </a:p>
-        </p:txBody>
-      </p:sp>
-      <p:sp>
-        <p:nvSpPr>
-          <p:cNvPr id="11" name="Rectangle 10"/>
-          <p:cNvSpPr/>
-          <p:nvPr/>
-        </p:nvSpPr>
-        <p:spPr>
-          <a:xfrm>
-            <a:off x="2331720" y="1417320"/>
-            <a:ext cx="18288" cy="3429000"/>
-          </a:xfrm>
-          <a:prstGeom prst="rect">
-            <a:avLst/>
-          </a:prstGeom>
-          <a:solidFill>
-            <a:srgbClr val="EB5955"/>
-          </a:solidFill>
-          <a:ln>
-            <a:solidFill>
-              <a:srgbClr val="EB5955"/>
-            </a:solidFill>
-          </a:ln>
-        </p:spPr>
-        <p:style>
-          <a:lnRef idx="1">
-            <a:schemeClr val="accent1"/>
-          </a:lnRef>
-          <a:fillRef idx="3">
-            <a:schemeClr val="accent1"/>
-          </a:fillRef>
-          <a:effectRef idx="2">
-            <a:schemeClr val="accent1"/>
-          </a:effectRef>
-          <a:fontRef idx="minor">
-            <a:schemeClr val="lt1"/>
-          </a:fontRef>
-        </p:style>
-        <p:txBody>
-          <a:bodyPr rtlCol="0" anchor="ctr"/>
-          <a:lstStyle/>
-          <a:p>
-            <a:pPr algn="ctr"/>
-          </a:p>
-        </p:txBody>
-      </p:sp>
-      <p:sp>
-        <p:nvSpPr>
-          <p:cNvPr id="12" name="TextBox 11"/>
-          <p:cNvSpPr txBox="1"/>
-          <p:nvPr/>
-        </p:nvSpPr>
-        <p:spPr>
-          <a:xfrm>
-            <a:off x="2971800" y="1325880"/>
-            <a:ext cx="6492240" cy="274320"/>
-          </a:xfrm>
-          <a:prstGeom prst="rect">
-            <a:avLst/>
-          </a:prstGeom>
-          <a:noFill/>
-        </p:spPr>
-        <p:txBody>
-          <a:bodyPr wrap="square" lIns="54864" rIns="54864" tIns="27432" bIns="27432">
-            <a:noAutofit/>
-          </a:bodyPr>
-          <a:lstStyle/>
-          <a:p>
-            <a:pPr algn="l"/>
-            <a:r>
               <a:rPr sz="1800" b="1">
                 <a:solidFill>
                   <a:srgbClr val="B80C0C"/>
@@ -4171,7 +3989,7 @@
       </p:sp>
       <p:sp>
         <p:nvSpPr>
-          <p:cNvPr id="13" name="TextBox 12"/>
+          <p:cNvPr id="11" name="TextBox 10"/>
           <p:cNvSpPr txBox="1"/>
           <p:nvPr/>
         </p:nvSpPr>
@@ -4242,7 +4060,7 @@
       </p:sp>
       <p:sp>
         <p:nvSpPr>
-          <p:cNvPr id="14" name="TextBox 13"/>
+          <p:cNvPr id="12" name="TextBox 11"/>
           <p:cNvSpPr txBox="1"/>
           <p:nvPr/>
         </p:nvSpPr>
@@ -4277,7 +4095,7 @@
       </p:sp>
       <p:sp>
         <p:nvSpPr>
-          <p:cNvPr id="15" name="TextBox 14"/>
+          <p:cNvPr id="13" name="TextBox 12"/>
           <p:cNvSpPr txBox="1"/>
           <p:nvPr/>
         </p:nvSpPr>
@@ -4428,26 +4246,50 @@
           </a:p>
         </p:txBody>
       </p:sp>
-      <p:sp>
-        <p:nvSpPr>
-          <p:cNvPr id="4" name="Rectangle 3"/>
+      <p:pic>
+        <p:nvPicPr>
+          <p:cNvPr id="4" name="Picture 3" descr="scu_logo_badge_crop.png"/>
+          <p:cNvPicPr>
+            <a:picLocks noChangeAspect="1"/>
+          </p:cNvPicPr>
+          <p:nvPr/>
+        </p:nvPicPr>
+        <p:blipFill>
+          <a:blip r:embed="rId2"/>
+          <a:stretch>
+            <a:fillRect/>
+          </a:stretch>
+        </p:blipFill>
+        <p:spPr>
+          <a:xfrm>
+            <a:off x="9720072" y="411480"/>
+            <a:ext cx="1691640" cy="658368"/>
+          </a:xfrm>
+          <a:prstGeom prst="rect">
+            <a:avLst/>
+          </a:prstGeom>
+        </p:spPr>
+      </p:pic>
+      <p:sp>
+        <p:nvSpPr>
+          <p:cNvPr id="5" name="Rectangle 4"/>
           <p:cNvSpPr/>
           <p:nvPr/>
         </p:nvSpPr>
         <p:spPr>
           <a:xfrm>
-            <a:off x="9710928" y="429768"/>
-            <a:ext cx="1737360" cy="475488"/>
+            <a:off x="658368" y="6236208"/>
+            <a:ext cx="10881360" cy="9144"/>
           </a:xfrm>
           <a:prstGeom prst="rect">
             <a:avLst/>
           </a:prstGeom>
           <a:solidFill>
-            <a:srgbClr val="B80C0C"/>
+            <a:srgbClr val="EB5955"/>
           </a:solidFill>
           <a:ln>
             <a:solidFill>
-              <a:srgbClr val="B80C0C"/>
+              <a:srgbClr val="EB5955"/>
             </a:solidFill>
           </a:ln>
         </p:spPr>
@@ -4475,14 +4317,14 @@
       </p:sp>
       <p:sp>
         <p:nvSpPr>
-          <p:cNvPr id="5" name="TextBox 4"/>
+          <p:cNvPr id="6" name="TextBox 5"/>
           <p:cNvSpPr txBox="1"/>
           <p:nvPr/>
         </p:nvSpPr>
         <p:spPr>
           <a:xfrm>
-            <a:off x="9857232" y="530352"/>
-            <a:ext cx="1417320" cy="201168"/>
+            <a:off x="658368" y="6318504"/>
+            <a:ext cx="2560320" cy="256032"/>
           </a:xfrm>
           <a:prstGeom prst="rect">
             <a:avLst/>
@@ -4495,29 +4337,29 @@
           </a:bodyPr>
           <a:lstStyle/>
           <a:p>
-            <a:pPr algn="ctr"/>
-            <a:r>
-              <a:rPr sz="1000" b="1">
-                <a:solidFill>
-                  <a:srgbClr val="FFFFFF"/>
-                </a:solidFill>
-                <a:latin typeface="SimHei"/>
+            <a:pPr algn="l"/>
+            <a:r>
+              <a:rPr sz="1200" b="0">
+                <a:solidFill>
+                  <a:srgbClr val="969696"/>
+                </a:solidFill>
+                <a:latin typeface="SimSun"/>
               </a:rPr>
-              <a:t>四川大学</a:t>
-            </a:r>
-          </a:p>
-        </p:txBody>
-      </p:sp>
-      <p:sp>
-        <p:nvSpPr>
-          <p:cNvPr id="6" name="TextBox 5"/>
+              <a:t>海纳百川，有容乃大</a:t>
+            </a:r>
+          </a:p>
+        </p:txBody>
+      </p:sp>
+      <p:sp>
+        <p:nvSpPr>
+          <p:cNvPr id="7" name="TextBox 6"/>
           <p:cNvSpPr txBox="1"/>
           <p:nvPr/>
         </p:nvSpPr>
         <p:spPr>
           <a:xfrm>
-            <a:off x="9857232" y="731520"/>
-            <a:ext cx="1417320" cy="118872"/>
+            <a:off x="9646920" y="6318504"/>
+            <a:ext cx="1920240" cy="256032"/>
           </a:xfrm>
           <a:prstGeom prst="rect">
             <a:avLst/>
@@ -4530,35 +4372,35 @@
           </a:bodyPr>
           <a:lstStyle/>
           <a:p>
-            <a:pPr algn="ctr"/>
-            <a:r>
-              <a:rPr sz="500" b="1">
-                <a:solidFill>
-                  <a:srgbClr val="FFFFFF"/>
-                </a:solidFill>
-                <a:latin typeface="Arial"/>
+            <a:pPr algn="r"/>
+            <a:r>
+              <a:rPr sz="1200" b="0">
+                <a:solidFill>
+                  <a:srgbClr val="969696"/>
+                </a:solidFill>
+                <a:latin typeface="SimSun"/>
               </a:rPr>
-              <a:t>SICHUAN UNIVERSITY</a:t>
-            </a:r>
-          </a:p>
-        </p:txBody>
-      </p:sp>
-      <p:sp>
-        <p:nvSpPr>
-          <p:cNvPr id="7" name="Rectangle 6"/>
+              <a:t>www.scu.edu.cn/</a:t>
+            </a:r>
+          </a:p>
+        </p:txBody>
+      </p:sp>
+      <p:sp>
+        <p:nvSpPr>
+          <p:cNvPr id="8" name="Rectangle 7"/>
           <p:cNvSpPr/>
           <p:nvPr/>
         </p:nvSpPr>
         <p:spPr>
           <a:xfrm>
-            <a:off x="658368" y="6236208"/>
-            <a:ext cx="10881360" cy="9144"/>
+            <a:off x="685800" y="1325880"/>
+            <a:ext cx="5074920" cy="1234440"/>
           </a:xfrm>
           <a:prstGeom prst="rect">
             <a:avLst/>
           </a:prstGeom>
           <a:solidFill>
-            <a:srgbClr val="EB5955"/>
+            <a:srgbClr val="FFFFFF"/>
           </a:solidFill>
           <a:ln>
             <a:solidFill>
@@ -4590,14 +4432,14 @@
       </p:sp>
       <p:sp>
         <p:nvSpPr>
-          <p:cNvPr id="8" name="TextBox 7"/>
+          <p:cNvPr id="9" name="TextBox 8"/>
           <p:cNvSpPr txBox="1"/>
           <p:nvPr/>
         </p:nvSpPr>
         <p:spPr>
           <a:xfrm>
-            <a:off x="658368" y="6318504"/>
-            <a:ext cx="2560320" cy="256032"/>
+            <a:off x="832104" y="1435608"/>
+            <a:ext cx="4782312" cy="292608"/>
           </a:xfrm>
           <a:prstGeom prst="rect">
             <a:avLst/>
@@ -4612,27 +4454,27 @@
           <a:p>
             <a:pPr algn="l"/>
             <a:r>
-              <a:rPr sz="1200" b="0">
-                <a:solidFill>
-                  <a:srgbClr val="969696"/>
-                </a:solidFill>
-                <a:latin typeface="SimSun"/>
+              <a:rPr sz="1600" b="1">
+                <a:solidFill>
+                  <a:srgbClr val="B80C0C"/>
+                </a:solidFill>
+                <a:latin typeface="SimHei"/>
               </a:rPr>
-              <a:t>海纳百川，有容乃大</a:t>
-            </a:r>
-          </a:p>
-        </p:txBody>
-      </p:sp>
-      <p:sp>
-        <p:nvSpPr>
-          <p:cNvPr id="9" name="TextBox 8"/>
+              <a:t>01 空间融合扩展</a:t>
+            </a:r>
+          </a:p>
+        </p:txBody>
+      </p:sp>
+      <p:sp>
+        <p:nvSpPr>
+          <p:cNvPr id="10" name="TextBox 9"/>
           <p:cNvSpPr txBox="1"/>
           <p:nvPr/>
         </p:nvSpPr>
         <p:spPr>
           <a:xfrm>
-            <a:off x="9646920" y="6318504"/>
-            <a:ext cx="1920240" cy="256032"/>
+            <a:off x="832104" y="1801368"/>
+            <a:ext cx="4782312" cy="649224"/>
           </a:xfrm>
           <a:prstGeom prst="rect">
             <a:avLst/>
@@ -4640,33 +4482,37 @@
           <a:noFill/>
         </p:spPr>
         <p:txBody>
-          <a:bodyPr wrap="square" lIns="54864" rIns="54864" tIns="27432" bIns="27432">
+          <a:bodyPr wrap="square" lIns="73152" rIns="73152">
             <a:noAutofit/>
           </a:bodyPr>
           <a:lstStyle/>
           <a:p>
-            <a:pPr algn="r"/>
-            <a:r>
-              <a:rPr sz="1200" b="0">
-                <a:solidFill>
-                  <a:srgbClr val="969696"/>
+            <a:pPr>
+              <a:spcAft>
+                <a:spcPts val="500"/>
+              </a:spcAft>
+            </a:pPr>
+            <a:r>
+              <a:rPr sz="1200">
+                <a:solidFill>
+                  <a:srgbClr val="181818"/>
                 </a:solidFill>
                 <a:latin typeface="SimSun"/>
               </a:rPr>
-              <a:t>www.scu.edu.cn/</a:t>
-            </a:r>
-          </a:p>
-        </p:txBody>
-      </p:sp>
-      <p:sp>
-        <p:nvSpPr>
-          <p:cNvPr id="10" name="Rectangle 9"/>
+              <a:t>优化南向“一环”主轴，推动西北“二环”衔接，强化西南与西北联动。</a:t>
+            </a:r>
+          </a:p>
+        </p:txBody>
+      </p:sp>
+      <p:sp>
+        <p:nvSpPr>
+          <p:cNvPr id="11" name="Rectangle 10"/>
           <p:cNvSpPr/>
           <p:nvPr/>
         </p:nvSpPr>
         <p:spPr>
           <a:xfrm>
-            <a:off x="685800" y="1325880"/>
+            <a:off x="6172200" y="1325880"/>
             <a:ext cx="5074920" cy="1234440"/>
           </a:xfrm>
           <a:prstGeom prst="rect">
@@ -4705,13 +4551,13 @@
       </p:sp>
       <p:sp>
         <p:nvSpPr>
-          <p:cNvPr id="11" name="TextBox 10"/>
+          <p:cNvPr id="12" name="TextBox 11"/>
           <p:cNvSpPr txBox="1"/>
           <p:nvPr/>
         </p:nvSpPr>
         <p:spPr>
           <a:xfrm>
-            <a:off x="832104" y="1435608"/>
+            <a:off x="6318504" y="1435608"/>
             <a:ext cx="4782312" cy="292608"/>
           </a:xfrm>
           <a:prstGeom prst="rect">
@@ -4733,20 +4579,20 @@
                 </a:solidFill>
                 <a:latin typeface="SimHei"/>
               </a:rPr>
-              <a:t>01 空间融合扩展</a:t>
-            </a:r>
-          </a:p>
-        </p:txBody>
-      </p:sp>
-      <p:sp>
-        <p:nvSpPr>
-          <p:cNvPr id="12" name="TextBox 11"/>
+              <a:t>02 产业互补协同</a:t>
+            </a:r>
+          </a:p>
+        </p:txBody>
+      </p:sp>
+      <p:sp>
+        <p:nvSpPr>
+          <p:cNvPr id="13" name="TextBox 12"/>
           <p:cNvSpPr txBox="1"/>
           <p:nvPr/>
         </p:nvSpPr>
         <p:spPr>
           <a:xfrm>
-            <a:off x="832104" y="1801368"/>
+            <a:off x="6318504" y="1801368"/>
             <a:ext cx="4782312" cy="649224"/>
           </a:xfrm>
           <a:prstGeom prst="rect">
@@ -4772,20 +4618,20 @@
                 </a:solidFill>
                 <a:latin typeface="SimSun"/>
               </a:rPr>
-              <a:t>优化南向“一环”主轴，推动西北“二环”衔接，强化西南与西北联动。</a:t>
-            </a:r>
-          </a:p>
-        </p:txBody>
-      </p:sp>
-      <p:sp>
-        <p:nvSpPr>
-          <p:cNvPr id="13" name="Rectangle 12"/>
+              <a:t>根据不同东盟经济体的竞争和互补程度，发展产业内贸易与产业间贸易。</a:t>
+            </a:r>
+          </a:p>
+        </p:txBody>
+      </p:sp>
+      <p:sp>
+        <p:nvSpPr>
+          <p:cNvPr id="14" name="Rectangle 13"/>
           <p:cNvSpPr/>
           <p:nvPr/>
         </p:nvSpPr>
         <p:spPr>
           <a:xfrm>
-            <a:off x="6172200" y="1325880"/>
+            <a:off x="685800" y="2788920"/>
             <a:ext cx="5074920" cy="1234440"/>
           </a:xfrm>
           <a:prstGeom prst="rect">
@@ -4824,13 +4670,13 @@
       </p:sp>
       <p:sp>
         <p:nvSpPr>
-          <p:cNvPr id="14" name="TextBox 13"/>
+          <p:cNvPr id="15" name="TextBox 14"/>
           <p:cNvSpPr txBox="1"/>
           <p:nvPr/>
         </p:nvSpPr>
         <p:spPr>
           <a:xfrm>
-            <a:off x="6318504" y="1435608"/>
+            <a:off x="832104" y="2898648"/>
             <a:ext cx="4782312" cy="292608"/>
           </a:xfrm>
           <a:prstGeom prst="rect">
@@ -4852,20 +4698,20 @@
                 </a:solidFill>
                 <a:latin typeface="SimHei"/>
               </a:rPr>
-              <a:t>02 产业互补协同</a:t>
-            </a:r>
-          </a:p>
-        </p:txBody>
-      </p:sp>
-      <p:sp>
-        <p:nvSpPr>
-          <p:cNvPr id="15" name="TextBox 14"/>
+              <a:t>03 贸易物流双向畅通</a:t>
+            </a:r>
+          </a:p>
+        </p:txBody>
+      </p:sp>
+      <p:sp>
+        <p:nvSpPr>
+          <p:cNvPr id="16" name="TextBox 15"/>
           <p:cNvSpPr txBox="1"/>
           <p:nvPr/>
         </p:nvSpPr>
         <p:spPr>
           <a:xfrm>
-            <a:off x="6318504" y="1801368"/>
+            <a:off x="832104" y="3264408"/>
             <a:ext cx="4782312" cy="649224"/>
           </a:xfrm>
           <a:prstGeom prst="rect">
@@ -4891,20 +4737,20 @@
                 </a:solidFill>
                 <a:latin typeface="SimSun"/>
               </a:rPr>
-              <a:t>根据不同东盟经济体的竞争和互补程度，发展产业内贸易与产业间贸易。</a:t>
-            </a:r>
-          </a:p>
-        </p:txBody>
-      </p:sp>
-      <p:sp>
-        <p:nvSpPr>
-          <p:cNvPr id="16" name="Rectangle 15"/>
+              <a:t>从单向出口转向进出口双向繁荣，提升铁、公、水、空多式联运效率。</a:t>
+            </a:r>
+          </a:p>
+        </p:txBody>
+      </p:sp>
+      <p:sp>
+        <p:nvSpPr>
+          <p:cNvPr id="17" name="Rectangle 16"/>
           <p:cNvSpPr/>
           <p:nvPr/>
         </p:nvSpPr>
         <p:spPr>
           <a:xfrm>
-            <a:off x="685800" y="2788920"/>
+            <a:off x="6172200" y="2788920"/>
             <a:ext cx="5074920" cy="1234440"/>
           </a:xfrm>
           <a:prstGeom prst="rect">
@@ -4943,13 +4789,13 @@
       </p:sp>
       <p:sp>
         <p:nvSpPr>
-          <p:cNvPr id="17" name="TextBox 16"/>
+          <p:cNvPr id="18" name="TextBox 17"/>
           <p:cNvSpPr txBox="1"/>
           <p:nvPr/>
         </p:nvSpPr>
         <p:spPr>
           <a:xfrm>
-            <a:off x="832104" y="2898648"/>
+            <a:off x="6318504" y="2898648"/>
             <a:ext cx="4782312" cy="292608"/>
           </a:xfrm>
           <a:prstGeom prst="rect">
@@ -4971,20 +4817,20 @@
                 </a:solidFill>
                 <a:latin typeface="SimHei"/>
               </a:rPr>
-              <a:t>03 贸易物流双向畅通</a:t>
-            </a:r>
-          </a:p>
-        </p:txBody>
-      </p:sp>
-      <p:sp>
-        <p:nvSpPr>
-          <p:cNvPr id="18" name="TextBox 17"/>
+              <a:t>04 区域协调机制</a:t>
+            </a:r>
+          </a:p>
+        </p:txBody>
+      </p:sp>
+      <p:sp>
+        <p:nvSpPr>
+          <p:cNvPr id="19" name="TextBox 18"/>
           <p:cNvSpPr txBox="1"/>
           <p:nvPr/>
         </p:nvSpPr>
         <p:spPr>
           <a:xfrm>
-            <a:off x="832104" y="3264408"/>
+            <a:off x="6318504" y="3264408"/>
             <a:ext cx="4782312" cy="649224"/>
           </a:xfrm>
           <a:prstGeom prst="rect">
@@ -5010,31 +4856,31 @@
                 </a:solidFill>
                 <a:latin typeface="SimSun"/>
               </a:rPr>
-              <a:t>从单向出口转向进出口双向繁荣，提升铁、公、水、空多式联运效率。</a:t>
-            </a:r>
-          </a:p>
-        </p:txBody>
-      </p:sp>
-      <p:sp>
-        <p:nvSpPr>
-          <p:cNvPr id="19" name="Rectangle 18"/>
+              <a:t>建立覆盖国内沿线省份与东盟经济体的常态化协商和政策沟通机制。</a:t>
+            </a:r>
+          </a:p>
+        </p:txBody>
+      </p:sp>
+      <p:sp>
+        <p:nvSpPr>
+          <p:cNvPr id="20" name="Rectangle 19"/>
           <p:cNvSpPr/>
           <p:nvPr/>
         </p:nvSpPr>
         <p:spPr>
           <a:xfrm>
-            <a:off x="6172200" y="2788920"/>
-            <a:ext cx="5074920" cy="1234440"/>
+            <a:off x="685800" y="4663440"/>
+            <a:ext cx="10561320" cy="822960"/>
           </a:xfrm>
           <a:prstGeom prst="rect">
             <a:avLst/>
           </a:prstGeom>
           <a:solidFill>
-            <a:srgbClr val="FFFFFF"/>
+            <a:srgbClr val="B80C0C"/>
           </a:solidFill>
           <a:ln>
             <a:solidFill>
-              <a:srgbClr val="EB5955"/>
+              <a:srgbClr val="B80C0C"/>
             </a:solidFill>
           </a:ln>
         </p:spPr>
@@ -5062,126 +4908,7 @@
       </p:sp>
       <p:sp>
         <p:nvSpPr>
-          <p:cNvPr id="20" name="TextBox 19"/>
-          <p:cNvSpPr txBox="1"/>
-          <p:nvPr/>
-        </p:nvSpPr>
-        <p:spPr>
-          <a:xfrm>
-            <a:off x="6318504" y="2898648"/>
-            <a:ext cx="4782312" cy="292608"/>
-          </a:xfrm>
-          <a:prstGeom prst="rect">
-            <a:avLst/>
-          </a:prstGeom>
-          <a:noFill/>
-        </p:spPr>
-        <p:txBody>
-          <a:bodyPr wrap="square" lIns="54864" rIns="54864" tIns="27432" bIns="27432">
-            <a:noAutofit/>
-          </a:bodyPr>
-          <a:lstStyle/>
-          <a:p>
-            <a:pPr algn="l"/>
-            <a:r>
-              <a:rPr sz="1600" b="1">
-                <a:solidFill>
-                  <a:srgbClr val="B80C0C"/>
-                </a:solidFill>
-                <a:latin typeface="SimHei"/>
-              </a:rPr>
-              <a:t>04 区域协调机制</a:t>
-            </a:r>
-          </a:p>
-        </p:txBody>
-      </p:sp>
-      <p:sp>
-        <p:nvSpPr>
           <p:cNvPr id="21" name="TextBox 20"/>
-          <p:cNvSpPr txBox="1"/>
-          <p:nvPr/>
-        </p:nvSpPr>
-        <p:spPr>
-          <a:xfrm>
-            <a:off x="6318504" y="3264408"/>
-            <a:ext cx="4782312" cy="649224"/>
-          </a:xfrm>
-          <a:prstGeom prst="rect">
-            <a:avLst/>
-          </a:prstGeom>
-          <a:noFill/>
-        </p:spPr>
-        <p:txBody>
-          <a:bodyPr wrap="square" lIns="73152" rIns="73152">
-            <a:noAutofit/>
-          </a:bodyPr>
-          <a:lstStyle/>
-          <a:p>
-            <a:pPr>
-              <a:spcAft>
-                <a:spcPts val="500"/>
-              </a:spcAft>
-            </a:pPr>
-            <a:r>
-              <a:rPr sz="1200">
-                <a:solidFill>
-                  <a:srgbClr val="181818"/>
-                </a:solidFill>
-                <a:latin typeface="SimSun"/>
-              </a:rPr>
-              <a:t>建立覆盖国内沿线省份与东盟经济体的常态化协商和政策沟通机制。</a:t>
-            </a:r>
-          </a:p>
-        </p:txBody>
-      </p:sp>
-      <p:sp>
-        <p:nvSpPr>
-          <p:cNvPr id="22" name="Rectangle 21"/>
-          <p:cNvSpPr/>
-          <p:nvPr/>
-        </p:nvSpPr>
-        <p:spPr>
-          <a:xfrm>
-            <a:off x="685800" y="4663440"/>
-            <a:ext cx="10561320" cy="822960"/>
-          </a:xfrm>
-          <a:prstGeom prst="rect">
-            <a:avLst/>
-          </a:prstGeom>
-          <a:solidFill>
-            <a:srgbClr val="B80C0C"/>
-          </a:solidFill>
-          <a:ln>
-            <a:solidFill>
-              <a:srgbClr val="B80C0C"/>
-            </a:solidFill>
-          </a:ln>
-        </p:spPr>
-        <p:style>
-          <a:lnRef idx="1">
-            <a:schemeClr val="accent1"/>
-          </a:lnRef>
-          <a:fillRef idx="3">
-            <a:schemeClr val="accent1"/>
-          </a:fillRef>
-          <a:effectRef idx="2">
-            <a:schemeClr val="accent1"/>
-          </a:effectRef>
-          <a:fontRef idx="minor">
-            <a:schemeClr val="lt1"/>
-          </a:fontRef>
-        </p:style>
-        <p:txBody>
-          <a:bodyPr rtlCol="0" anchor="ctr"/>
-          <a:lstStyle/>
-          <a:p>
-            <a:pPr algn="ctr"/>
-          </a:p>
-        </p:txBody>
-      </p:sp>
-      <p:sp>
-        <p:nvSpPr>
-          <p:cNvPr id="23" name="TextBox 22"/>
           <p:cNvSpPr txBox="1"/>
           <p:nvPr/>
         </p:nvSpPr>

</xml_diff>